<commit_message>
Align deliverables to evaluation rubric
</commit_message>
<xml_diff>
--- a/outputs/presentation/Marketing_Analytics_Executive_Deck_v4.pptx
+++ b/outputs/presentation/Marketing_Analytics_Executive_Deck_v4.pptx
@@ -26,6 +26,7 @@
     <p:sldId id="274" r:id="rId25"/>
     <p:sldId id="275" r:id="rId26"/>
     <p:sldId id="276" r:id="rId27"/>
+    <p:sldId id="277" r:id="rId28"/>
   </p:sldIdLst>
   <p:sldSz cx="12188952" cy="6858000" type="screen4x3"/>
   <p:notesSz cx="6858000" cy="9144000"/>
@@ -7765,6 +7766,930 @@
 </file>
 
 <file path=ppt/slides/slide21.xml><?xml version="1.0" encoding="utf-8"?>
+<p:sld xmlns:a="http://schemas.openxmlformats.org/drawingml/2006/main" xmlns:p="http://schemas.openxmlformats.org/presentationml/2006/main" xmlns:r="http://schemas.openxmlformats.org/officeDocument/2006/relationships">
+  <p:cSld>
+    <p:spTree>
+      <p:nvGrpSpPr>
+        <p:cNvPr id="1" name=""/>
+        <p:cNvGrpSpPr/>
+        <p:nvPr/>
+      </p:nvGrpSpPr>
+      <p:grpSpPr/>
+      <p:sp>
+        <p:nvSpPr>
+          <p:cNvPr id="2" name="TextBox 1"/>
+          <p:cNvSpPr txBox="1"/>
+          <p:nvPr/>
+        </p:nvSpPr>
+        <p:spPr>
+          <a:xfrm>
+            <a:off x="274320" y="91440"/>
+            <a:ext cx="11430000" cy="685800"/>
+          </a:xfrm>
+          <a:prstGeom prst="rect">
+            <a:avLst/>
+          </a:prstGeom>
+          <a:noFill/>
+        </p:spPr>
+        <p:txBody>
+          <a:bodyPr wrap="square">
+            <a:spAutoFit/>
+          </a:bodyPr>
+          <a:lstStyle/>
+          <a:p>
+            <a:pPr>
+              <a:defRPr sz="2200" b="1">
+                <a:solidFill>
+                  <a:srgbClr val="2563EB"/>
+                </a:solidFill>
+              </a:defRPr>
+            </a:pPr>
+            <a:r>
+              <a:t>Rubric Alignment</a:t>
+            </a:r>
+          </a:p>
+          <a:p>
+            <a:pPr>
+              <a:defRPr sz="1100">
+                <a:solidFill>
+                  <a:srgbClr val="64748B"/>
+                </a:solidFill>
+              </a:defRPr>
+            </a:pPr>
+            <a:r>
+              <a:t>How the analysis answers the case prompt and evaluation criteria</a:t>
+            </a:r>
+          </a:p>
+        </p:txBody>
+      </p:sp>
+      <p:sp>
+        <p:nvSpPr>
+          <p:cNvPr id="3" name="Rectangle 2"/>
+          <p:cNvSpPr/>
+          <p:nvPr/>
+        </p:nvSpPr>
+        <p:spPr>
+          <a:xfrm>
+            <a:off x="320040" y="868680"/>
+            <a:ext cx="11567160" cy="493776"/>
+          </a:xfrm>
+          <a:prstGeom prst="rect">
+            <a:avLst/>
+          </a:prstGeom>
+          <a:solidFill>
+            <a:srgbClr val="F1F5F9"/>
+          </a:solidFill>
+          <a:ln w="15240">
+            <a:solidFill>
+              <a:srgbClr val="2563EB"/>
+            </a:solidFill>
+          </a:ln>
+        </p:spPr>
+        <p:style>
+          <a:lnRef idx="1">
+            <a:schemeClr val="accent1"/>
+          </a:lnRef>
+          <a:fillRef idx="3">
+            <a:schemeClr val="accent1"/>
+          </a:fillRef>
+          <a:effectRef idx="2">
+            <a:schemeClr val="accent1"/>
+          </a:effectRef>
+          <a:fontRef idx="minor">
+            <a:schemeClr val="lt1"/>
+          </a:fontRef>
+        </p:style>
+        <p:txBody>
+          <a:bodyPr rtlCol="0" anchor="ctr"/>
+          <a:lstStyle/>
+          <a:p>
+            <a:pPr algn="ctr"/>
+          </a:p>
+        </p:txBody>
+      </p:sp>
+      <p:sp>
+        <p:nvSpPr>
+          <p:cNvPr id="4" name="TextBox 3"/>
+          <p:cNvSpPr txBox="1"/>
+          <p:nvPr/>
+        </p:nvSpPr>
+        <p:spPr>
+          <a:xfrm>
+            <a:off x="502920" y="941832"/>
+            <a:ext cx="2194560" cy="320040"/>
+          </a:xfrm>
+          <a:prstGeom prst="rect">
+            <a:avLst/>
+          </a:prstGeom>
+          <a:noFill/>
+        </p:spPr>
+        <p:txBody>
+          <a:bodyPr wrap="square">
+            <a:spAutoFit/>
+          </a:bodyPr>
+          <a:lstStyle/>
+          <a:p>
+            <a:pPr algn="l">
+              <a:defRPr sz="1050" b="1">
+                <a:solidFill>
+                  <a:srgbClr val="2563EB"/>
+                </a:solidFill>
+              </a:defRPr>
+            </a:pPr>
+            <a:r>
+              <a:t>Data Processing</a:t>
+            </a:r>
+          </a:p>
+        </p:txBody>
+      </p:sp>
+      <p:sp>
+        <p:nvSpPr>
+          <p:cNvPr id="5" name="TextBox 4"/>
+          <p:cNvSpPr txBox="1"/>
+          <p:nvPr/>
+        </p:nvSpPr>
+        <p:spPr>
+          <a:xfrm>
+            <a:off x="2743200" y="941832"/>
+            <a:ext cx="8961120" cy="320040"/>
+          </a:xfrm>
+          <a:prstGeom prst="rect">
+            <a:avLst/>
+          </a:prstGeom>
+          <a:noFill/>
+        </p:spPr>
+        <p:txBody>
+          <a:bodyPr wrap="square">
+            <a:spAutoFit/>
+          </a:bodyPr>
+          <a:lstStyle/>
+          <a:p>
+            <a:pPr algn="l">
+              <a:defRPr sz="1000" b="0">
+                <a:solidFill>
+                  <a:srgbClr val="1E293B"/>
+                </a:solidFill>
+              </a:defRPr>
+            </a:pPr>
+            <a:r>
+              <a:t>8-source pipeline, cleaned parquet layers, domain-based integration</a:t>
+            </a:r>
+          </a:p>
+        </p:txBody>
+      </p:sp>
+      <p:sp>
+        <p:nvSpPr>
+          <p:cNvPr id="6" name="Rectangle 5"/>
+          <p:cNvSpPr/>
+          <p:nvPr/>
+        </p:nvSpPr>
+        <p:spPr>
+          <a:xfrm>
+            <a:off x="320040" y="1490472"/>
+            <a:ext cx="11567160" cy="493776"/>
+          </a:xfrm>
+          <a:prstGeom prst="rect">
+            <a:avLst/>
+          </a:prstGeom>
+          <a:solidFill>
+            <a:srgbClr val="F1F5F9"/>
+          </a:solidFill>
+          <a:ln w="15240">
+            <a:solidFill>
+              <a:srgbClr val="2563EB"/>
+            </a:solidFill>
+          </a:ln>
+        </p:spPr>
+        <p:style>
+          <a:lnRef idx="1">
+            <a:schemeClr val="accent1"/>
+          </a:lnRef>
+          <a:fillRef idx="3">
+            <a:schemeClr val="accent1"/>
+          </a:fillRef>
+          <a:effectRef idx="2">
+            <a:schemeClr val="accent1"/>
+          </a:effectRef>
+          <a:fontRef idx="minor">
+            <a:schemeClr val="lt1"/>
+          </a:fontRef>
+        </p:style>
+        <p:txBody>
+          <a:bodyPr rtlCol="0" anchor="ctr"/>
+          <a:lstStyle/>
+          <a:p>
+            <a:pPr algn="ctr"/>
+          </a:p>
+        </p:txBody>
+      </p:sp>
+      <p:sp>
+        <p:nvSpPr>
+          <p:cNvPr id="7" name="TextBox 6"/>
+          <p:cNvSpPr txBox="1"/>
+          <p:nvPr/>
+        </p:nvSpPr>
+        <p:spPr>
+          <a:xfrm>
+            <a:off x="502920" y="1563624"/>
+            <a:ext cx="2194560" cy="320040"/>
+          </a:xfrm>
+          <a:prstGeom prst="rect">
+            <a:avLst/>
+          </a:prstGeom>
+          <a:noFill/>
+        </p:spPr>
+        <p:txBody>
+          <a:bodyPr wrap="square">
+            <a:spAutoFit/>
+          </a:bodyPr>
+          <a:lstStyle/>
+          <a:p>
+            <a:pPr algn="l">
+              <a:defRPr sz="1050" b="1">
+                <a:solidFill>
+                  <a:srgbClr val="2563EB"/>
+                </a:solidFill>
+              </a:defRPr>
+            </a:pPr>
+            <a:r>
+              <a:t>Data Integrity</a:t>
+            </a:r>
+          </a:p>
+        </p:txBody>
+      </p:sp>
+      <p:sp>
+        <p:nvSpPr>
+          <p:cNvPr id="8" name="TextBox 7"/>
+          <p:cNvSpPr txBox="1"/>
+          <p:nvPr/>
+        </p:nvSpPr>
+        <p:spPr>
+          <a:xfrm>
+            <a:off x="2743200" y="1563624"/>
+            <a:ext cx="8961120" cy="320040"/>
+          </a:xfrm>
+          <a:prstGeom prst="rect">
+            <a:avLst/>
+          </a:prstGeom>
+          <a:noFill/>
+        </p:spPr>
+        <p:txBody>
+          <a:bodyPr wrap="square">
+            <a:spAutoFit/>
+          </a:bodyPr>
+          <a:lstStyle/>
+          <a:p>
+            <a:pPr algn="l">
+              <a:defRPr sz="1000" b="0">
+                <a:solidFill>
+                  <a:srgbClr val="1E293B"/>
+                </a:solidFill>
+              </a:defRPr>
+            </a:pPr>
+            <a:r>
+              <a:t>Validation checks for booleans, won/closed logic, dashboard sync, and caveats</a:t>
+            </a:r>
+          </a:p>
+        </p:txBody>
+      </p:sp>
+      <p:sp>
+        <p:nvSpPr>
+          <p:cNvPr id="9" name="Rectangle 8"/>
+          <p:cNvSpPr/>
+          <p:nvPr/>
+        </p:nvSpPr>
+        <p:spPr>
+          <a:xfrm>
+            <a:off x="320040" y="2112264"/>
+            <a:ext cx="11567160" cy="493776"/>
+          </a:xfrm>
+          <a:prstGeom prst="rect">
+            <a:avLst/>
+          </a:prstGeom>
+          <a:solidFill>
+            <a:srgbClr val="F1F5F9"/>
+          </a:solidFill>
+          <a:ln w="15240">
+            <a:solidFill>
+              <a:srgbClr val="2563EB"/>
+            </a:solidFill>
+          </a:ln>
+        </p:spPr>
+        <p:style>
+          <a:lnRef idx="1">
+            <a:schemeClr val="accent1"/>
+          </a:lnRef>
+          <a:fillRef idx="3">
+            <a:schemeClr val="accent1"/>
+          </a:fillRef>
+          <a:effectRef idx="2">
+            <a:schemeClr val="accent1"/>
+          </a:effectRef>
+          <a:fontRef idx="minor">
+            <a:schemeClr val="lt1"/>
+          </a:fontRef>
+        </p:style>
+        <p:txBody>
+          <a:bodyPr rtlCol="0" anchor="ctr"/>
+          <a:lstStyle/>
+          <a:p>
+            <a:pPr algn="ctr"/>
+          </a:p>
+        </p:txBody>
+      </p:sp>
+      <p:sp>
+        <p:nvSpPr>
+          <p:cNvPr id="10" name="TextBox 9"/>
+          <p:cNvSpPr txBox="1"/>
+          <p:nvPr/>
+        </p:nvSpPr>
+        <p:spPr>
+          <a:xfrm>
+            <a:off x="502920" y="2185416"/>
+            <a:ext cx="2194560" cy="320040"/>
+          </a:xfrm>
+          <a:prstGeom prst="rect">
+            <a:avLst/>
+          </a:prstGeom>
+          <a:noFill/>
+        </p:spPr>
+        <p:txBody>
+          <a:bodyPr wrap="square">
+            <a:spAutoFit/>
+          </a:bodyPr>
+          <a:lstStyle/>
+          <a:p>
+            <a:pPr algn="l">
+              <a:defRPr sz="1050" b="1">
+                <a:solidFill>
+                  <a:srgbClr val="2563EB"/>
+                </a:solidFill>
+              </a:defRPr>
+            </a:pPr>
+            <a:r>
+              <a:t>Data Storytelling</a:t>
+            </a:r>
+          </a:p>
+        </p:txBody>
+      </p:sp>
+      <p:sp>
+        <p:nvSpPr>
+          <p:cNvPr id="11" name="TextBox 10"/>
+          <p:cNvSpPr txBox="1"/>
+          <p:nvPr/>
+        </p:nvSpPr>
+        <p:spPr>
+          <a:xfrm>
+            <a:off x="2743200" y="2185416"/>
+            <a:ext cx="8961120" cy="320040"/>
+          </a:xfrm>
+          <a:prstGeom prst="rect">
+            <a:avLst/>
+          </a:prstGeom>
+          <a:noFill/>
+        </p:spPr>
+        <p:txBody>
+          <a:bodyPr wrap="square">
+            <a:spAutoFit/>
+          </a:bodyPr>
+          <a:lstStyle/>
+          <a:p>
+            <a:pPr algn="l">
+              <a:defRPr sz="1000" b="0">
+                <a:solidFill>
+                  <a:srgbClr val="1E293B"/>
+                </a:solidFill>
+              </a:defRPr>
+            </a:pPr>
+            <a:r>
+              <a:t>Essential View leads with the CMO decision before analyst detail</a:t>
+            </a:r>
+          </a:p>
+        </p:txBody>
+      </p:sp>
+      <p:sp>
+        <p:nvSpPr>
+          <p:cNvPr id="12" name="Rectangle 11"/>
+          <p:cNvSpPr/>
+          <p:nvPr/>
+        </p:nvSpPr>
+        <p:spPr>
+          <a:xfrm>
+            <a:off x="320040" y="2734056"/>
+            <a:ext cx="11567160" cy="493776"/>
+          </a:xfrm>
+          <a:prstGeom prst="rect">
+            <a:avLst/>
+          </a:prstGeom>
+          <a:solidFill>
+            <a:srgbClr val="F1F5F9"/>
+          </a:solidFill>
+          <a:ln w="15240">
+            <a:solidFill>
+              <a:srgbClr val="2563EB"/>
+            </a:solidFill>
+          </a:ln>
+        </p:spPr>
+        <p:style>
+          <a:lnRef idx="1">
+            <a:schemeClr val="accent1"/>
+          </a:lnRef>
+          <a:fillRef idx="3">
+            <a:schemeClr val="accent1"/>
+          </a:fillRef>
+          <a:effectRef idx="2">
+            <a:schemeClr val="accent1"/>
+          </a:effectRef>
+          <a:fontRef idx="minor">
+            <a:schemeClr val="lt1"/>
+          </a:fontRef>
+        </p:style>
+        <p:txBody>
+          <a:bodyPr rtlCol="0" anchor="ctr"/>
+          <a:lstStyle/>
+          <a:p>
+            <a:pPr algn="ctr"/>
+          </a:p>
+        </p:txBody>
+      </p:sp>
+      <p:sp>
+        <p:nvSpPr>
+          <p:cNvPr id="13" name="TextBox 12"/>
+          <p:cNvSpPr txBox="1"/>
+          <p:nvPr/>
+        </p:nvSpPr>
+        <p:spPr>
+          <a:xfrm>
+            <a:off x="502920" y="2807208"/>
+            <a:ext cx="2194560" cy="320040"/>
+          </a:xfrm>
+          <a:prstGeom prst="rect">
+            <a:avLst/>
+          </a:prstGeom>
+          <a:noFill/>
+        </p:spPr>
+        <p:txBody>
+          <a:bodyPr wrap="square">
+            <a:spAutoFit/>
+          </a:bodyPr>
+          <a:lstStyle/>
+          <a:p>
+            <a:pPr algn="l">
+              <a:defRPr sz="1050" b="1">
+                <a:solidFill>
+                  <a:srgbClr val="2563EB"/>
+                </a:solidFill>
+              </a:defRPr>
+            </a:pPr>
+            <a:r>
+              <a:t>Dashboard Design</a:t>
+            </a:r>
+          </a:p>
+        </p:txBody>
+      </p:sp>
+      <p:sp>
+        <p:nvSpPr>
+          <p:cNvPr id="14" name="TextBox 13"/>
+          <p:cNvSpPr txBox="1"/>
+          <p:nvPr/>
+        </p:nvSpPr>
+        <p:spPr>
+          <a:xfrm>
+            <a:off x="2743200" y="2807208"/>
+            <a:ext cx="8961120" cy="320040"/>
+          </a:xfrm>
+          <a:prstGeom prst="rect">
+            <a:avLst/>
+          </a:prstGeom>
+          <a:noFill/>
+        </p:spPr>
+        <p:txBody>
+          <a:bodyPr wrap="square">
+            <a:spAutoFit/>
+          </a:bodyPr>
+          <a:lstStyle/>
+          <a:p>
+            <a:pPr algn="l">
+              <a:defRPr sz="1000" b="0">
+                <a:solidFill>
+                  <a:srgbClr val="1E293B"/>
+                </a:solidFill>
+              </a:defRPr>
+            </a:pPr>
+            <a:r>
+              <a:t>Decision-critical charts first; deeper methodology and tables are drill-downs</a:t>
+            </a:r>
+          </a:p>
+        </p:txBody>
+      </p:sp>
+      <p:sp>
+        <p:nvSpPr>
+          <p:cNvPr id="15" name="Rectangle 14"/>
+          <p:cNvSpPr/>
+          <p:nvPr/>
+        </p:nvSpPr>
+        <p:spPr>
+          <a:xfrm>
+            <a:off x="320040" y="3355848"/>
+            <a:ext cx="11567160" cy="493776"/>
+          </a:xfrm>
+          <a:prstGeom prst="rect">
+            <a:avLst/>
+          </a:prstGeom>
+          <a:solidFill>
+            <a:srgbClr val="F1F5F9"/>
+          </a:solidFill>
+          <a:ln w="15240">
+            <a:solidFill>
+              <a:srgbClr val="10B981"/>
+            </a:solidFill>
+          </a:ln>
+        </p:spPr>
+        <p:style>
+          <a:lnRef idx="1">
+            <a:schemeClr val="accent1"/>
+          </a:lnRef>
+          <a:fillRef idx="3">
+            <a:schemeClr val="accent1"/>
+          </a:fillRef>
+          <a:effectRef idx="2">
+            <a:schemeClr val="accent1"/>
+          </a:effectRef>
+          <a:fontRef idx="minor">
+            <a:schemeClr val="lt1"/>
+          </a:fontRef>
+        </p:style>
+        <p:txBody>
+          <a:bodyPr rtlCol="0" anchor="ctr"/>
+          <a:lstStyle/>
+          <a:p>
+            <a:pPr algn="ctr"/>
+          </a:p>
+        </p:txBody>
+      </p:sp>
+      <p:sp>
+        <p:nvSpPr>
+          <p:cNvPr id="16" name="TextBox 15"/>
+          <p:cNvSpPr txBox="1"/>
+          <p:nvPr/>
+        </p:nvSpPr>
+        <p:spPr>
+          <a:xfrm>
+            <a:off x="502920" y="3429000"/>
+            <a:ext cx="2194560" cy="320040"/>
+          </a:xfrm>
+          <a:prstGeom prst="rect">
+            <a:avLst/>
+          </a:prstGeom>
+          <a:noFill/>
+        </p:spPr>
+        <p:txBody>
+          <a:bodyPr wrap="square">
+            <a:spAutoFit/>
+          </a:bodyPr>
+          <a:lstStyle/>
+          <a:p>
+            <a:pPr algn="l">
+              <a:defRPr sz="1050" b="1">
+                <a:solidFill>
+                  <a:srgbClr val="2563EB"/>
+                </a:solidFill>
+              </a:defRPr>
+            </a:pPr>
+            <a:r>
+              <a:t>Reporting &amp; Analysis</a:t>
+            </a:r>
+          </a:p>
+        </p:txBody>
+      </p:sp>
+      <p:sp>
+        <p:nvSpPr>
+          <p:cNvPr id="17" name="TextBox 16"/>
+          <p:cNvSpPr txBox="1"/>
+          <p:nvPr/>
+        </p:nvSpPr>
+        <p:spPr>
+          <a:xfrm>
+            <a:off x="2743200" y="3429000"/>
+            <a:ext cx="8961120" cy="320040"/>
+          </a:xfrm>
+          <a:prstGeom prst="rect">
+            <a:avLst/>
+          </a:prstGeom>
+          <a:noFill/>
+        </p:spPr>
+        <p:txBody>
+          <a:bodyPr wrap="square">
+            <a:spAutoFit/>
+          </a:bodyPr>
+          <a:lstStyle/>
+          <a:p>
+            <a:pPr algn="l">
+              <a:defRPr sz="1000" b="0">
+                <a:solidFill>
+                  <a:srgbClr val="1E293B"/>
+                </a:solidFill>
+              </a:defRPr>
+            </a:pPr>
+            <a:r>
+              <a:t>Attribution, channel ROI, coverage, cohort, targeting, and budget evidence</a:t>
+            </a:r>
+          </a:p>
+        </p:txBody>
+      </p:sp>
+      <p:sp>
+        <p:nvSpPr>
+          <p:cNvPr id="18" name="Rectangle 17"/>
+          <p:cNvSpPr/>
+          <p:nvPr/>
+        </p:nvSpPr>
+        <p:spPr>
+          <a:xfrm>
+            <a:off x="320040" y="3977640"/>
+            <a:ext cx="11567160" cy="493776"/>
+          </a:xfrm>
+          <a:prstGeom prst="rect">
+            <a:avLst/>
+          </a:prstGeom>
+          <a:solidFill>
+            <a:srgbClr val="F1F5F9"/>
+          </a:solidFill>
+          <a:ln w="15240">
+            <a:solidFill>
+              <a:srgbClr val="10B981"/>
+            </a:solidFill>
+          </a:ln>
+        </p:spPr>
+        <p:style>
+          <a:lnRef idx="1">
+            <a:schemeClr val="accent1"/>
+          </a:lnRef>
+          <a:fillRef idx="3">
+            <a:schemeClr val="accent1"/>
+          </a:fillRef>
+          <a:effectRef idx="2">
+            <a:schemeClr val="accent1"/>
+          </a:effectRef>
+          <a:fontRef idx="minor">
+            <a:schemeClr val="lt1"/>
+          </a:fontRef>
+        </p:style>
+        <p:txBody>
+          <a:bodyPr rtlCol="0" anchor="ctr"/>
+          <a:lstStyle/>
+          <a:p>
+            <a:pPr algn="ctr"/>
+          </a:p>
+        </p:txBody>
+      </p:sp>
+      <p:sp>
+        <p:nvSpPr>
+          <p:cNvPr id="19" name="TextBox 18"/>
+          <p:cNvSpPr txBox="1"/>
+          <p:nvPr/>
+        </p:nvSpPr>
+        <p:spPr>
+          <a:xfrm>
+            <a:off x="502920" y="4050792"/>
+            <a:ext cx="2194560" cy="320040"/>
+          </a:xfrm>
+          <a:prstGeom prst="rect">
+            <a:avLst/>
+          </a:prstGeom>
+          <a:noFill/>
+        </p:spPr>
+        <p:txBody>
+          <a:bodyPr wrap="square">
+            <a:spAutoFit/>
+          </a:bodyPr>
+          <a:lstStyle/>
+          <a:p>
+            <a:pPr algn="l">
+              <a:defRPr sz="1050" b="1">
+                <a:solidFill>
+                  <a:srgbClr val="2563EB"/>
+                </a:solidFill>
+              </a:defRPr>
+            </a:pPr>
+            <a:r>
+              <a:t>Marketing Strategy</a:t>
+            </a:r>
+          </a:p>
+        </p:txBody>
+      </p:sp>
+      <p:sp>
+        <p:nvSpPr>
+          <p:cNvPr id="20" name="TextBox 19"/>
+          <p:cNvSpPr txBox="1"/>
+          <p:nvPr/>
+        </p:nvSpPr>
+        <p:spPr>
+          <a:xfrm>
+            <a:off x="2743200" y="4050792"/>
+            <a:ext cx="8961120" cy="320040"/>
+          </a:xfrm>
+          <a:prstGeom prst="rect">
+            <a:avLst/>
+          </a:prstGeom>
+          <a:noFill/>
+        </p:spPr>
+        <p:txBody>
+          <a:bodyPr wrap="square">
+            <a:spAutoFit/>
+          </a:bodyPr>
+          <a:lstStyle/>
+          <a:p>
+            <a:pPr algn="l">
+              <a:defRPr sz="1000" b="0">
+                <a:solidFill>
+                  <a:srgbClr val="1E293B"/>
+                </a:solidFill>
+              </a:defRPr>
+            </a:pPr>
+            <a:r>
+              <a:t>Protect quality, expand strong-fit coverage, and test budget shifts before scaling</a:t>
+            </a:r>
+          </a:p>
+        </p:txBody>
+      </p:sp>
+      <p:sp>
+        <p:nvSpPr>
+          <p:cNvPr id="21" name="Rectangle 20"/>
+          <p:cNvSpPr/>
+          <p:nvPr/>
+        </p:nvSpPr>
+        <p:spPr>
+          <a:xfrm>
+            <a:off x="320040" y="4599432"/>
+            <a:ext cx="11567160" cy="493776"/>
+          </a:xfrm>
+          <a:prstGeom prst="rect">
+            <a:avLst/>
+          </a:prstGeom>
+          <a:solidFill>
+            <a:srgbClr val="F1F5F9"/>
+          </a:solidFill>
+          <a:ln w="15240">
+            <a:solidFill>
+              <a:srgbClr val="10B981"/>
+            </a:solidFill>
+          </a:ln>
+        </p:spPr>
+        <p:style>
+          <a:lnRef idx="1">
+            <a:schemeClr val="accent1"/>
+          </a:lnRef>
+          <a:fillRef idx="3">
+            <a:schemeClr val="accent1"/>
+          </a:fillRef>
+          <a:effectRef idx="2">
+            <a:schemeClr val="accent1"/>
+          </a:effectRef>
+          <a:fontRef idx="minor">
+            <a:schemeClr val="lt1"/>
+          </a:fontRef>
+        </p:style>
+        <p:txBody>
+          <a:bodyPr rtlCol="0" anchor="ctr"/>
+          <a:lstStyle/>
+          <a:p>
+            <a:pPr algn="ctr"/>
+          </a:p>
+        </p:txBody>
+      </p:sp>
+      <p:sp>
+        <p:nvSpPr>
+          <p:cNvPr id="22" name="TextBox 21"/>
+          <p:cNvSpPr txBox="1"/>
+          <p:nvPr/>
+        </p:nvSpPr>
+        <p:spPr>
+          <a:xfrm>
+            <a:off x="502920" y="4672584"/>
+            <a:ext cx="2194560" cy="320040"/>
+          </a:xfrm>
+          <a:prstGeom prst="rect">
+            <a:avLst/>
+          </a:prstGeom>
+          <a:noFill/>
+        </p:spPr>
+        <p:txBody>
+          <a:bodyPr wrap="square">
+            <a:spAutoFit/>
+          </a:bodyPr>
+          <a:lstStyle/>
+          <a:p>
+            <a:pPr algn="l">
+              <a:defRPr sz="1050" b="1">
+                <a:solidFill>
+                  <a:srgbClr val="2563EB"/>
+                </a:solidFill>
+              </a:defRPr>
+            </a:pPr>
+            <a:r>
+              <a:t>Presentation</a:t>
+            </a:r>
+          </a:p>
+        </p:txBody>
+      </p:sp>
+      <p:sp>
+        <p:nvSpPr>
+          <p:cNvPr id="23" name="TextBox 22"/>
+          <p:cNvSpPr txBox="1"/>
+          <p:nvPr/>
+        </p:nvSpPr>
+        <p:spPr>
+          <a:xfrm>
+            <a:off x="2743200" y="4672584"/>
+            <a:ext cx="8961120" cy="320040"/>
+          </a:xfrm>
+          <a:prstGeom prst="rect">
+            <a:avLst/>
+          </a:prstGeom>
+          <a:noFill/>
+        </p:spPr>
+        <p:txBody>
+          <a:bodyPr wrap="square">
+            <a:spAutoFit/>
+          </a:bodyPr>
+          <a:lstStyle/>
+          <a:p>
+            <a:pPr algn="l">
+              <a:defRPr sz="1000" b="0">
+                <a:solidFill>
+                  <a:srgbClr val="1E293B"/>
+                </a:solidFill>
+              </a:defRPr>
+            </a:pPr>
+            <a:r>
+              <a:t>Talk track starts with the business problem, then proves the recommendation</a:t>
+            </a:r>
+          </a:p>
+        </p:txBody>
+      </p:sp>
+      <p:sp>
+        <p:nvSpPr>
+          <p:cNvPr id="24" name="Rectangle 23"/>
+          <p:cNvSpPr/>
+          <p:nvPr/>
+        </p:nvSpPr>
+        <p:spPr>
+          <a:xfrm>
+            <a:off x="228600" y="5788152"/>
+            <a:ext cx="11750040" cy="987552"/>
+          </a:xfrm>
+          <a:prstGeom prst="rect">
+            <a:avLst/>
+          </a:prstGeom>
+          <a:solidFill>
+            <a:srgbClr val="EFF6FF"/>
+          </a:solidFill>
+          <a:ln w="12700">
+            <a:solidFill>
+              <a:srgbClr val="2563EB"/>
+            </a:solidFill>
+          </a:ln>
+        </p:spPr>
+        <p:style>
+          <a:lnRef idx="1">
+            <a:schemeClr val="accent1"/>
+          </a:lnRef>
+          <a:fillRef idx="3">
+            <a:schemeClr val="accent1"/>
+          </a:fillRef>
+          <a:effectRef idx="2">
+            <a:schemeClr val="accent1"/>
+          </a:effectRef>
+          <a:fontRef idx="minor">
+            <a:schemeClr val="lt1"/>
+          </a:fontRef>
+        </p:style>
+        <p:txBody>
+          <a:bodyPr rtlCol="0" anchor="ctr" wrap="square"/>
+          <a:lstStyle/>
+          <a:p>
+            <a:pPr algn="ctr">
+              <a:defRPr sz="950">
+                <a:solidFill>
+                  <a:srgbClr val="1E40AF"/>
+                </a:solidFill>
+              </a:defRPr>
+            </a:pPr>
+            <a:r>
+              <a:t>WHAT THIS SHOWS: This slide makes the scoring rubric explicit. HOW TO PRESENT: Do not read every row. Say that the project satisfies the case prompt end to end: reproducible processing, validated metrics, focused storytelling, appropriate dashboard design, and a practical CMO marketing strategy.</a:t>
+            </a:r>
+          </a:p>
+        </p:txBody>
+      </p:sp>
+    </p:spTree>
+  </p:cSld>
+  <p:clrMapOvr>
+    <a:masterClrMapping/>
+  </p:clrMapOvr>
+</p:sld>
+</file>
+
+<file path=ppt/slides/slide22.xml><?xml version="1.0" encoding="utf-8"?>
 <p:sld xmlns:a="http://schemas.openxmlformats.org/drawingml/2006/main" xmlns:p="http://schemas.openxmlformats.org/presentationml/2006/main" xmlns:r="http://schemas.openxmlformats.org/officeDocument/2006/relationships">
   <p:cSld>
     <p:spTree>

</xml_diff>